<commit_message>
feat(diarios-del-pais): primera ronda de aprendizaje activo del tono
- 60 titulares elegidos por incertidumbre, etiquetados a mano
  (labels_activo.json). El modelo coincidia con la etiqueta humana en el 42%.
- Reentrenado con 400 titulares: acierto sobre la muestra representativa
  76% -> 76% (recall de negativas 84% -> 85%); en los casos activos 37%,
  casi el azar: son titulares ambiguos, no errores aprendibles.
- El acierto y la calibracion se miden solo sobre los 340 originales.
- Informe y presentacion con el resultado de la ronda.

Co-Authored-By: Claude Opus 5.5 <noreply@anthropic.com>
</commit_message>
<xml_diff>
--- a/docs/presentacion-tp.pptx
+++ b/docs/presentacion-tp.pptx
@@ -131,18 +131,18 @@
   <p:extLst>
     <p:ext uri="{521415D9-36F7-43E2-AB2F-B90AF26B5E84}">
       <p14:sectionLst xmlns:p14="http://schemas.microsoft.com/office/powerpoint/2010/main">
-        <p14:section name="Apertura" id="{586e4289-a590-1a03-14f0-58b980e8dec4}">
+        <p14:section name="Apertura" id="{93ea5e1d-5e86-f31e-902c-b97e5094f4ac}">
           <p14:sldIdLst>
             <p14:sldId id="256"/>
           </p14:sldIdLst>
         </p14:section>
-        <p14:section name="Problema" id="{94062e0d-5809-ccfd-df4e-0fb88bb95b34}">
+        <p14:section name="Problema" id="{56da9b91-3e27-96aa-37f2-f9527ec52396}">
           <p14:sldIdLst>
             <p14:sldId id="257"/>
             <p14:sldId id="258"/>
           </p14:sldIdLst>
         </p14:section>
-        <p14:section name="Cómo funciona" id="{3c75d1b5-bc39-1f71-8f4d-bbcc376c0521}">
+        <p14:section name="Cómo funciona" id="{0afe72ac-9e5d-f485-b1d1-fd317001aee4}">
           <p14:sldIdLst>
             <p14:sldId id="259"/>
             <p14:sldId id="260"/>
@@ -154,7 +154,7 @@
             <p14:sldId id="266"/>
           </p14:sldIdLst>
         </p14:section>
-        <p14:section name="Qué encontramos" id="{cb945d4d-aabb-fd22-1340-9a83886991e7}">
+        <p14:section name="Qué encontramos" id="{7b737213-3f9b-4da9-1c64-259f92bdb675}">
           <p14:sldIdLst>
             <p14:sldId id="267"/>
             <p14:sldId id="268"/>
@@ -167,7 +167,7 @@
             <p14:sldId id="275"/>
           </p14:sldIdLst>
         </p14:section>
-        <p14:section name="Cierre" id="{f179b449-c666-7ace-ccdd-480431db7851}">
+        <p14:section name="Cierre" id="{0f916704-ac10-b7ca-efdb-3af129763910}">
           <p14:sldIdLst>
             <p14:sldId id="276"/>
             <p14:sldId id="277"/>
@@ -2312,7 +2312,7 @@
           <a:p>
             <a:r>
               <a:rPr lang="en-US" dirty="0"/>
-              <a:t>Tres técnicas para que el sistema no dependa solo de listas fijas. NER con spaCy descubre figuras nuevas, como Fundación Faro o Gonzalo Belloso. Los embeddings de oraciones encuentran la misma noticia contada con otras palabras y permiten buscar por significado desde el navegador. El aprendizaje activo elige los titulares donde el modelo de tono duda para que los etiquetemos a mano: el modelo pide ayuda donde más la necesita.</a:t>
+              <a:t>Tres técnicas para que el sistema no dependa solo de listas fijas. NER con spaCy descubre figuras nuevas, como Fundación Faro o Gonzalo Belloso. Los embeddings de oraciones encuentran la misma noticia contada con otras palabras y permiten buscar por significado desde el navegador. El aprendizaje activo elige los titulares donde el modelo de tono duda para que los etiquetemos a mano: el modelo pide ayuda donde más la necesita. En la primera ronda (60 titulares) el acierto se mantuvo en 76%: el modelo coincidía con nosotros solo en el 42% de esos casos y, aun reentrenado, acierta el 37% en ellos, casi el azar. Conclusión honesta: no eran errores aprendibles sino titulares ambiguos; la ronda sirvió para delimitar la frontera del criterio.</a:t>
             </a:r>
             <a:endParaRPr lang="en-US" dirty="0"/>
           </a:p>
@@ -6047,7 +6047,7 @@
                 <a:ea typeface="Calibri" pitchFamily="34" charset="-122"/>
                 <a:cs typeface="Calibri" pitchFamily="34" charset="-120"/>
               </a:rPr>
-              <a:t>El modelo de tono elige los 60 titulares donde más duda para etiquetarlos a mano y reentrenar.</a:t>
+              <a:t>El modelo de tono eligió los 60 titulares donde más dudaba; los etiquetamos a mano y reentrenamos.</a:t>
             </a:r>
             <a:endParaRPr lang="en-US" sz="1500" dirty="0"/>
           </a:p>
@@ -6086,7 +6086,7 @@
                 <a:ea typeface="Calibri" pitchFamily="34" charset="-122"/>
                 <a:cs typeface="Calibri" pitchFamily="34" charset="-120"/>
               </a:rPr>
-              <a:t>Tema de la clase 3, aplicado</a:t>
+              <a:t>Resultado: 76% → 76%; eran casos ambiguos</a:t>
             </a:r>
             <a:endParaRPr lang="en-US" sz="1400" dirty="0"/>
           </a:p>

</xml_diff>

<commit_message>
feat(diarios-del-pais): dolar contra clima mediatico, pruebas, acciones nuevas y limpieza
- Dolar: tabla dolar (blue y oficial, historico diario de argentinadatos.com
  y valor del dia de dolarapi.com) y seccion "Clima mediatico y dolar" en
  Tendencias: dos graficos con el mismo eje de dias y correlacion de Pearson
  con la variacion diaria del blue cuando hay al menos 8 dias.
- Pruebas: tests/test_extraccion.py (bajadas, mojibake, JSON-LD, firma,
  robots.txt simulado, cebo, entidades, temas, limpieza NER) y un trabajo
  "pruebas" en el workflow que corre en paralelo sin frenar los datos.
- Acciones actualizadas a Node 24: checkout v7, setup-python v7, cache v6,
  upload-pages-artifact v5, deploy-pages v5.
- Limpieza: se quitan tono_entrenar.py, crear_planilla_validacion.py,
  labels_respaldo.json, Actualizar.bat y archivar.py.
- Documentacion: autodisparo cada 30 minutos, pruebas y dolar.

Co-Authored-By: Claude Opus 5.5 <noreply@anthropic.com>
</commit_message>
<xml_diff>
--- a/docs/presentacion-tp.pptx
+++ b/docs/presentacion-tp.pptx
@@ -131,18 +131,18 @@
   <p:extLst>
     <p:ext uri="{521415D9-36F7-43E2-AB2F-B90AF26B5E84}">
       <p14:sectionLst xmlns:p14="http://schemas.microsoft.com/office/powerpoint/2010/main">
-        <p14:section name="Apertura" id="{93ea5e1d-5e86-f31e-902c-b97e5094f4ac}">
+        <p14:section name="Apertura" id="{8a2ec515-e8f7-3554-3d8f-c80a7cceb027}">
           <p14:sldIdLst>
             <p14:sldId id="256"/>
           </p14:sldIdLst>
         </p14:section>
-        <p14:section name="Problema" id="{56da9b91-3e27-96aa-37f2-f9527ec52396}">
+        <p14:section name="Problema" id="{a8e7a517-75e6-4294-bad1-df95cd66844d}">
           <p14:sldIdLst>
             <p14:sldId id="257"/>
             <p14:sldId id="258"/>
           </p14:sldIdLst>
         </p14:section>
-        <p14:section name="Cómo funciona" id="{0afe72ac-9e5d-f485-b1d1-fd317001aee4}">
+        <p14:section name="Cómo funciona" id="{c1a2326d-6535-a386-05f5-1c1bb5eaa6a2}">
           <p14:sldIdLst>
             <p14:sldId id="259"/>
             <p14:sldId id="260"/>
@@ -154,7 +154,7 @@
             <p14:sldId id="266"/>
           </p14:sldIdLst>
         </p14:section>
-        <p14:section name="Qué encontramos" id="{7b737213-3f9b-4da9-1c64-259f92bdb675}">
+        <p14:section name="Qué encontramos" id="{539d5d2a-5ae0-3259-b662-9b7ee0bbb488}">
           <p14:sldIdLst>
             <p14:sldId id="267"/>
             <p14:sldId id="268"/>
@@ -167,7 +167,7 @@
             <p14:sldId id="275"/>
           </p14:sldIdLst>
         </p14:section>
-        <p14:section name="Cierre" id="{0f916704-ac10-b7ca-efdb-3af129763910}">
+        <p14:section name="Cierre" id="{48c7c7cb-4d8c-2327-4190-f868de807b78}">
           <p14:sldIdLst>
             <p14:sldId id="276"/>
             <p14:sldId id="277"/>
@@ -9974,7 +9974,7 @@
                 <a:ea typeface="Calibri" pitchFamily="34" charset="-122"/>
                 <a:cs typeface="Calibri" pitchFamily="34" charset="-120"/>
               </a:rPr>
-              <a:t>titulares por corrida, de 46 medios, cada hora</a:t>
+              <a:t>titulares por corrida, de 46 medios, cada media hora</a:t>
             </a:r>
             <a:endParaRPr lang="en-US" sz="1700" dirty="0"/>
           </a:p>
@@ -12192,7 +12192,7 @@
                 <a:ea typeface="Calibri" pitchFamily="34" charset="-122"/>
                 <a:cs typeface="Calibri" pitchFamily="34" charset="-120"/>
               </a:rPr>
-              <a:t>GitHub Actions (cada hora) · rama de datos</a:t>
+              <a:t>GitHub Actions (cada 30 min, autodisparo) · pruebas automáticas</a:t>
             </a:r>
             <a:endParaRPr lang="en-US" sz="1500" dirty="0"/>
           </a:p>
@@ -12817,7 +12817,7 @@
                 <a:ea typeface="Calibri" pitchFamily="34" charset="-122"/>
                 <a:cs typeface="Calibri" pitchFamily="34" charset="-120"/>
               </a:rPr>
-              <a:t>Cruzar el termómetro con el dólar y otros datos</a:t>
+              <a:t>Con más días: ¿el tono acompaña al dólar?</a:t>
             </a:r>
             <a:endParaRPr lang="en-US" sz="1600" dirty="0"/>
           </a:p>
@@ -13231,7 +13231,7 @@
                 <a:ea typeface="Cambria" pitchFamily="34" charset="-122"/>
                 <a:cs typeface="Cambria" pitchFamily="34" charset="-120"/>
               </a:rPr>
-              <a:t>Un monitor que corre solo, cada hora, y publica todo</a:t>
+              <a:t>Un monitor que corre solo, cada 30 minutos, y publica todo</a:t>
             </a:r>
             <a:endParaRPr lang="en-US" sz="3200" dirty="0"/>
           </a:p>
@@ -13465,7 +13465,7 @@
                 <a:ea typeface="Calibri" pitchFamily="34" charset="-122"/>
                 <a:cs typeface="Calibri" pitchFamily="34" charset="-120"/>
               </a:rPr>
-              <a:t>GitHub Actions cada hora; tablero y base SQL publicados en GitHub Pages</a:t>
+              <a:t>GitHub Actions cada 30 minutos; tablero y base SQL publicados en GitHub Pages</a:t>
             </a:r>
             <a:endParaRPr lang="en-US" sz="1500" dirty="0"/>
           </a:p>
@@ -14731,7 +14731,7 @@
                 <a:ea typeface="Calibri" pitchFamily="34" charset="-122"/>
                 <a:cs typeface="Calibri" pitchFamily="34" charset="-120"/>
               </a:rPr>
-              <a:t>GitHub Actions corre el pipeline cada hora, guarda la base en una rama de datos y publica el tablero en GitHub Pages. La primera corrida con BERT tarda 10 minutos; las siguientes, 2.</a:t>
+              <a:t>GitHub Actions corre el pipeline cada 30 minutos, guarda la base en una rama de datos y publica el tablero en GitHub Pages. La primera corrida con BERT tarda 10 minutos; las siguientes, 2.</a:t>
             </a:r>
             <a:endParaRPr lang="en-US" sz="1600" dirty="0"/>
           </a:p>

</xml_diff>